<commit_message>
added a section on the poster about the problem
</commit_message>
<xml_diff>
--- a/milestone/poster_template.pptx
+++ b/milestone/poster_template.pptx
@@ -2275,7 +2275,7 @@
         <p:spPr>
           <a:xfrm>
             <a:off x="112713" y="1270000"/>
-            <a:ext cx="3498850" cy="7656513"/>
+            <a:ext cx="3498850" cy="8538143"/>
           </a:xfrm>
           <a:ln/>
         </p:spPr>
@@ -2284,115 +2284,166 @@
           <a:lstStyle/>
           <a:p>
             <a:r>
-              <a:rPr lang="en-US" sz="1800">
+              <a:rPr lang="en-US" sz="1800" dirty="0">
                 <a:latin typeface="Bodoni MT" charset="0"/>
                 <a:cs typeface="Helvetica Neue" charset="0"/>
               </a:rPr>
-              <a:t>MAIN HEADINGS – BODONI MT 18PT ALL CAPS</a:t>
-            </a:r>
-          </a:p>
-          <a:p>
-            <a:endParaRPr lang="en-US" sz="1600">
+              <a:t>The Problem</a:t>
+            </a:r>
+          </a:p>
+          <a:p>
+            <a:r>
+              <a:rPr lang="en-US" dirty="0">
+                <a:latin typeface="Helvetica Neue" charset="0"/>
+                <a:cs typeface="Helvetica Neue" charset="0"/>
+              </a:rPr>
+              <a:t>Brisbane is among the fastest growing populations in the world with a current population of approximately 2.5 million people and counting.</a:t>
+            </a:r>
+            <a:endParaRPr lang="en-US" sz="1800" dirty="0">
               <a:latin typeface="Bodoni MT" charset="0"/>
               <a:cs typeface="Helvetica Neue" charset="0"/>
             </a:endParaRPr>
           </a:p>
           <a:p>
             <a:r>
-              <a:rPr lang="en-US" b="1">
+              <a:rPr lang="en-US" b="1" dirty="0">
                 <a:latin typeface="Helvetica Neue" charset="0"/>
                 <a:cs typeface="Helvetica Neue" charset="0"/>
               </a:rPr>
-              <a:t>Subheadings – Helvetica Neue Bold 14pt</a:t>
-            </a:r>
-          </a:p>
-          <a:p>
-            <a:r>
-              <a:rPr lang="en-US">
+              <a:t>2032 Olympic Games</a:t>
+            </a:r>
+          </a:p>
+          <a:p>
+            <a:r>
+              <a:rPr lang="en-US" dirty="0">
                 <a:latin typeface="Helvetica Neue" charset="0"/>
                 <a:cs typeface="Helvetica Neue" charset="0"/>
               </a:rPr>
-              <a:t>Body Text – Helvetica Neue 14pt (min 12pt)</a:t>
-            </a:r>
-          </a:p>
-          <a:p>
-            <a:endParaRPr lang="en-US">
-              <a:latin typeface="Helvetica Neue" charset="0"/>
-              <a:cs typeface="Helvetica Neue" charset="0"/>
-            </a:endParaRPr>
-          </a:p>
-          <a:p>
-            <a:r>
-              <a:rPr lang="en-US" b="1">
+              <a:t>Additionally with the upcoming 2032 Olympic games the city's population is going to grow exponentially.</a:t>
+            </a:r>
+          </a:p>
+          <a:p>
+            <a:r>
+              <a:rPr lang="en-US" b="1" dirty="0">
                 <a:latin typeface="Helvetica Neue" charset="0"/>
                 <a:cs typeface="Helvetica Neue" charset="0"/>
               </a:rPr>
-              <a:t>Don’t have the above fonts installed?</a:t>
-            </a:r>
-          </a:p>
-          <a:p>
-            <a:r>
-              <a:rPr lang="en-US">
+              <a:t>Why is this important?</a:t>
+            </a:r>
+          </a:p>
+          <a:p>
+            <a:r>
+              <a:rPr lang="en-US" dirty="0">
                 <a:latin typeface="Helvetica Neue" charset="0"/>
                 <a:cs typeface="Helvetica Neue" charset="0"/>
               </a:rPr>
-              <a:t>Substitutes for Bodoni MT:</a:t>
-            </a:r>
-          </a:p>
-          <a:p>
-            <a:r>
-              <a:rPr lang="en-US">
-                <a:latin typeface="Didot" charset="0"/>
-                <a:cs typeface="Helvetica Neue" charset="0"/>
-              </a:rPr>
-              <a:t>Didot on Apple</a:t>
-            </a:r>
-          </a:p>
-          <a:p>
-            <a:r>
-              <a:rPr lang="en-US">
-                <a:latin typeface="Times New Roman" charset="0"/>
-                <a:cs typeface="Times New Roman" charset="0"/>
-              </a:rPr>
-              <a:t>or Times New Roman (Apple &amp; Windows)</a:t>
-            </a:r>
-          </a:p>
-          <a:p>
-            <a:endParaRPr lang="en-US">
-              <a:latin typeface="Helvetica Neue" charset="0"/>
-              <a:cs typeface="Helvetica Neue" charset="0"/>
-            </a:endParaRPr>
-          </a:p>
-          <a:p>
-            <a:r>
-              <a:rPr lang="en-US">
+              <a:t>More people means more housing, more planes overhead and more noise. Accompanying this, the more people consequently means the more urban areas are stretched into industrial areas or outer city areas. Creating a domino effect of the following:</a:t>
+            </a:r>
+          </a:p>
+          <a:p>
+            <a:pPr marL="285750" indent="-285750">
+              <a:buFont typeface="Arial" panose="020B0604020202020204" pitchFamily="34" charset="0"/>
+              <a:buChar char="•"/>
+            </a:pPr>
+            <a:r>
+              <a:rPr lang="en-US" b="1" dirty="0">
                 <a:latin typeface="Helvetica Neue" charset="0"/>
                 <a:cs typeface="Helvetica Neue" charset="0"/>
               </a:rPr>
-              <a:t>Substitutes for Helvetica Neue:</a:t>
-            </a:r>
-          </a:p>
-          <a:p>
-            <a:r>
-              <a:rPr lang="en-US">
-                <a:latin typeface="Helvetica" charset="0"/>
-                <a:cs typeface="Helvetica" charset="0"/>
+              <a:t>Longer Travel</a:t>
+            </a:r>
+          </a:p>
+          <a:p>
+            <a:pPr marL="285750" indent="-285750">
+              <a:buFont typeface="Arial" panose="020B0604020202020204" pitchFamily="34" charset="0"/>
+              <a:buChar char="•"/>
+            </a:pPr>
+            <a:r>
+              <a:rPr lang="en-US" b="1" dirty="0">
+                <a:latin typeface="Helvetica Neue" charset="0"/>
+                <a:cs typeface="Helvetica Neue" charset="0"/>
               </a:rPr>
-              <a:t>Helvetica (Apple)</a:t>
-            </a:r>
-          </a:p>
-          <a:p>
-            <a:r>
-              <a:rPr lang="en-US">
-                <a:latin typeface="Arial" charset="0"/>
-                <a:cs typeface="Arial" charset="0"/>
+              <a:t>Busier Roads</a:t>
+            </a:r>
+          </a:p>
+          <a:p>
+            <a:pPr marL="285750" indent="-285750">
+              <a:buFont typeface="Arial" panose="020B0604020202020204" pitchFamily="34" charset="0"/>
+              <a:buChar char="•"/>
+            </a:pPr>
+            <a:r>
+              <a:rPr lang="en-US" b="1" dirty="0">
+                <a:latin typeface="Helvetica Neue" charset="0"/>
+                <a:cs typeface="Helvetica Neue" charset="0"/>
               </a:rPr>
-              <a:t>or Arial (Apple &amp; Windows)</a:t>
-            </a:r>
-          </a:p>
-          <a:p>
-            <a:endParaRPr lang="en-US">
-              <a:latin typeface="Helvetica Neue" charset="0"/>
+              <a:t>Houses in high noise areas</a:t>
+            </a:r>
+          </a:p>
+          <a:p>
+            <a:r>
+              <a:rPr lang="en-US" dirty="0">
+                <a:latin typeface="Helvetica Neue" charset="0"/>
+                <a:cs typeface="Helvetica Neue" charset="0"/>
+              </a:rPr>
+              <a:t>Exposing people to health risks of more gas </a:t>
+            </a:r>
+            <a:r>
+              <a:rPr lang="en-US" dirty="0" err="1">
+                <a:latin typeface="Helvetica Neue" charset="0"/>
+                <a:cs typeface="Helvetica Neue" charset="0"/>
+              </a:rPr>
+              <a:t>emittions</a:t>
+            </a:r>
+            <a:r>
+              <a:rPr lang="en-US" dirty="0">
+                <a:latin typeface="Helvetica Neue" charset="0"/>
+                <a:cs typeface="Helvetica Neue" charset="0"/>
+              </a:rPr>
+              <a:t> from both cars and factories, Reduced Sleep and more.</a:t>
+            </a:r>
+          </a:p>
+          <a:p>
+            <a:r>
+              <a:rPr lang="en-US" sz="1800" b="1" dirty="0">
+                <a:latin typeface="+mn-lt"/>
+                <a:cs typeface="Helvetica Neue" charset="0"/>
+              </a:rPr>
+              <a:t>We Believe Brisbane </a:t>
+            </a:r>
+            <a:r>
+              <a:rPr lang="en-US" sz="1800" b="1" i="1" dirty="0">
+                <a:latin typeface="+mn-lt"/>
+                <a:cs typeface="Helvetica Neue" charset="0"/>
+              </a:rPr>
+              <a:t>deserves better.</a:t>
+            </a:r>
+          </a:p>
+          <a:p>
+            <a:r>
+              <a:rPr lang="en-US" dirty="0">
+                <a:latin typeface="Helvetica Neue" charset="0"/>
+                <a:cs typeface="Helvetica Neue" charset="0"/>
+              </a:rPr>
+              <a:t>While we know we can’t in this project stop the development of houses and urbanization of industrial areas. We believe every single bit of info helps which is why we have produced the solution which can help </a:t>
+            </a:r>
+            <a:r>
+              <a:rPr lang="en-US" dirty="0" err="1">
+                <a:latin typeface="Helvetica Neue" charset="0"/>
+                <a:cs typeface="Helvetica Neue" charset="0"/>
+              </a:rPr>
+              <a:t>Brisbanians</a:t>
+            </a:r>
+            <a:r>
+              <a:rPr lang="en-US" dirty="0">
+                <a:latin typeface="Helvetica Neue" charset="0"/>
+                <a:cs typeface="Helvetica Neue" charset="0"/>
+              </a:rPr>
+              <a:t> create informed decisions on their housing like never before.</a:t>
+            </a:r>
+          </a:p>
+          <a:p>
+            <a:endParaRPr lang="en-US" sz="1800" b="1" i="1" dirty="0">
+              <a:latin typeface="+mn-lt"/>
               <a:cs typeface="Helvetica Neue" charset="0"/>
             </a:endParaRPr>
           </a:p>
@@ -2410,8 +2461,8 @@
         </p:nvSpPr>
         <p:spPr>
           <a:xfrm>
-            <a:off x="449263" y="-25400"/>
-            <a:ext cx="14312900" cy="698500"/>
+            <a:off x="-947056" y="-25400"/>
+            <a:ext cx="15709220" cy="698500"/>
           </a:xfrm>
         </p:spPr>
         <p:txBody>
@@ -2423,7 +2474,7 @@
                 <a:latin typeface="Bodoni MT" charset="0"/>
                 <a:cs typeface="Didot" charset="0"/>
               </a:rPr>
-              <a:t>TITLE OF YOUR PROJECT (BODONI MT 48PT)</a:t>
+              <a:t>Tracking Aircraft for a Sustainable Future for Brisbane</a:t>
             </a:r>
           </a:p>
         </p:txBody>
@@ -2440,8 +2491,8 @@
         </p:nvSpPr>
         <p:spPr>
           <a:xfrm>
-            <a:off x="4403725" y="673100"/>
-            <a:ext cx="10331450" cy="441325"/>
+            <a:off x="-404261" y="673100"/>
+            <a:ext cx="15139436" cy="441325"/>
           </a:xfrm>
         </p:spPr>
         <p:txBody>
@@ -2458,36 +2509,20 @@
                 <a:latin typeface="Helvetica Neue" charset="0"/>
                 <a:cs typeface="Helvetica Neue" charset="0"/>
               </a:rPr>
-              <a:t>Your Names and Team ID (A, B, </a:t>
-            </a:r>
-            <a:r>
-              <a:rPr lang="en-US" dirty="0" err="1">
-                <a:latin typeface="Helvetica Neue" charset="0"/>
-                <a:cs typeface="Helvetica Neue" charset="0"/>
-              </a:rPr>
-              <a:t>etc</a:t>
-            </a:r>
-            <a:r>
-              <a:rPr lang="en-US" dirty="0">
-                <a:latin typeface="Helvetica Neue" charset="0"/>
-                <a:cs typeface="Helvetica Neue" charset="0"/>
-              </a:rPr>
-              <a:t>) (Helvetica </a:t>
-            </a:r>
-            <a:r>
-              <a:rPr lang="en-US" dirty="0" err="1">
-                <a:latin typeface="Helvetica Neue" charset="0"/>
-                <a:cs typeface="Helvetica Neue" charset="0"/>
-              </a:rPr>
-              <a:t>Neue</a:t>
-            </a:r>
-            <a:r>
-              <a:rPr lang="en-US" dirty="0">
-                <a:latin typeface="Helvetica Neue" charset="0"/>
-                <a:cs typeface="Helvetica Neue" charset="0"/>
-              </a:rPr>
-              <a:t> 24pt)</a:t>
-            </a:r>
+              <a:t>Sidney Neil, Fiachra Richards, Xander Akison - </a:t>
+            </a:r>
+            <a:r>
+              <a:rPr lang="en-AU" dirty="0"/>
+              <a:t>Wheat </a:t>
+            </a:r>
+            <a:r>
+              <a:rPr lang="en-AU" dirty="0" err="1"/>
+              <a:t>Weywot</a:t>
+            </a:r>
+            <a:endParaRPr lang="en-US" dirty="0">
+              <a:latin typeface="Helvetica Neue" charset="0"/>
+              <a:cs typeface="Helvetica Neue" charset="0"/>
+            </a:endParaRPr>
           </a:p>
         </p:txBody>
       </p:sp>
@@ -2513,165 +2548,24 @@
           <a:lstStyle/>
           <a:p>
             <a:r>
-              <a:rPr lang="en-US" b="1">
-                <a:latin typeface="Helvetica Neue" charset="0"/>
+              <a:rPr lang="en-US" sz="1800" dirty="0">
+                <a:latin typeface="Bodoni MT" charset="0"/>
                 <a:cs typeface="Helvetica Neue" charset="0"/>
               </a:rPr>
-              <a:t>General Hints &amp; Tips</a:t>
-            </a:r>
-          </a:p>
-          <a:p>
-            <a:r>
-              <a:rPr lang="en-US" b="1" i="1">
-                <a:latin typeface="Helvetica Neue" charset="0"/>
-                <a:cs typeface="Helvetica Neue" charset="0"/>
-              </a:rPr>
-              <a:t>Do not </a:t>
-            </a:r>
-            <a:r>
-              <a:rPr lang="en-US">
-                <a:latin typeface="Helvetica Neue" charset="0"/>
-                <a:cs typeface="Helvetica Neue" charset="0"/>
-              </a:rPr>
-              <a:t>change the colour/size/logos/positioning of the Slide Master.</a:t>
-            </a:r>
-          </a:p>
-          <a:p>
-            <a:r>
-              <a:rPr lang="en-US">
-                <a:latin typeface="Helvetica Neue" charset="0"/>
-                <a:cs typeface="Helvetica Neue" charset="0"/>
-              </a:rPr>
-              <a:t>This is a standard format across all Innovation Expo posters.</a:t>
-            </a:r>
-          </a:p>
-          <a:p>
-            <a:r>
-              <a:rPr lang="en-US" b="1" i="1">
-                <a:latin typeface="Helvetica Neue" charset="0"/>
-                <a:cs typeface="Helvetica Neue" charset="0"/>
-              </a:rPr>
-              <a:t>Do not </a:t>
-            </a:r>
-            <a:r>
-              <a:rPr lang="en-US">
-                <a:latin typeface="Helvetica Neue" charset="0"/>
-                <a:cs typeface="Helvetica Neue" charset="0"/>
-              </a:rPr>
-              <a:t>add other corporate logos. This is an infringement of copyright, unless you have express permission to do so.</a:t>
-            </a:r>
-          </a:p>
-          <a:p>
-            <a:r>
-              <a:rPr lang="en-US" b="1" i="1">
-                <a:latin typeface="Helvetica Neue" charset="0"/>
-                <a:cs typeface="Helvetica Neue" charset="0"/>
-              </a:rPr>
-              <a:t>Do</a:t>
-            </a:r>
-            <a:r>
-              <a:rPr lang="en-US">
-                <a:latin typeface="Helvetica Neue" charset="0"/>
-                <a:cs typeface="Helvetica Neue" charset="0"/>
-              </a:rPr>
-              <a:t> use this space as creatively as you wish.</a:t>
-            </a:r>
-          </a:p>
-          <a:p>
-            <a:r>
-              <a:rPr lang="en-US" b="1" i="1">
-                <a:latin typeface="Helvetica Neue" charset="0"/>
-                <a:cs typeface="Helvetica Neue" charset="0"/>
-              </a:rPr>
-              <a:t>Avoid </a:t>
-            </a:r>
-            <a:r>
-              <a:rPr lang="en-US">
-                <a:latin typeface="Helvetica Neue" charset="0"/>
-                <a:cs typeface="Helvetica Neue" charset="0"/>
-              </a:rPr>
-              <a:t>using large background colours – doesn’t print well.</a:t>
-            </a:r>
-          </a:p>
-          <a:p>
-            <a:r>
-              <a:rPr lang="en-US" b="1" i="1">
-                <a:latin typeface="Helvetica Neue" charset="0"/>
-                <a:cs typeface="Helvetica Neue" charset="0"/>
-              </a:rPr>
-              <a:t>Stick to </a:t>
-            </a:r>
-            <a:r>
-              <a:rPr lang="en-US">
-                <a:latin typeface="Helvetica Neue" charset="0"/>
-                <a:cs typeface="Helvetica Neue" charset="0"/>
-              </a:rPr>
-              <a:t>the basic fonts &amp; sizes (left) – these read clearly. If you need to reduce the text size, you are trying to put too much on your poster.</a:t>
-            </a:r>
-          </a:p>
-          <a:p>
-            <a:r>
-              <a:rPr lang="en-US" b="1" i="1">
-                <a:latin typeface="Helvetica Neue" charset="0"/>
-                <a:cs typeface="Helvetica Neue" charset="0"/>
-              </a:rPr>
-              <a:t>As a check</a:t>
-            </a:r>
-            <a:r>
-              <a:rPr lang="en-US">
-                <a:latin typeface="Helvetica Neue" charset="0"/>
-                <a:cs typeface="Helvetica Neue" charset="0"/>
-              </a:rPr>
-              <a:t>, print “scaled to fit” onto A4 and read at arms length.</a:t>
-            </a:r>
-          </a:p>
-          <a:p>
-            <a:r>
-              <a:rPr lang="en-US" b="1" i="1">
-                <a:latin typeface="Helvetica Neue" charset="0"/>
-                <a:cs typeface="Helvetica Neue" charset="0"/>
-              </a:rPr>
-              <a:t>Save </a:t>
-            </a:r>
-            <a:r>
-              <a:rPr lang="en-US">
-                <a:latin typeface="Helvetica Neue" charset="0"/>
-                <a:cs typeface="Helvetica Neue" charset="0"/>
-              </a:rPr>
-              <a:t>your poster as you work on it.</a:t>
-            </a:r>
-          </a:p>
-          <a:p>
-            <a:r>
-              <a:rPr lang="en-US" b="1" i="1">
-                <a:latin typeface="Helvetica Neue" charset="0"/>
-                <a:cs typeface="Helvetica Neue" charset="0"/>
-              </a:rPr>
-              <a:t>You shouldn’t</a:t>
-            </a:r>
-            <a:r>
-              <a:rPr lang="en-US">
-                <a:latin typeface="Helvetica Neue" charset="0"/>
-                <a:cs typeface="Helvetica Neue" charset="0"/>
-              </a:rPr>
-              <a:t> need to change the sizing of this file, it should already be landscape format with width: 41cm and height: 28.7 cm (A3 with 5 mm borders all around).</a:t>
-            </a:r>
-          </a:p>
-          <a:p>
-            <a:r>
-              <a:rPr lang="en-US" b="1" i="1">
-                <a:latin typeface="Helvetica Neue" charset="0"/>
-                <a:cs typeface="Helvetica Neue" charset="0"/>
-              </a:rPr>
-              <a:t>The title </a:t>
-            </a:r>
-            <a:r>
-              <a:rPr lang="en-US">
-                <a:latin typeface="Helvetica Neue" charset="0"/>
-                <a:cs typeface="Helvetica Neue" charset="0"/>
-              </a:rPr>
-              <a:t>may look to close to the top edge – don’t be tempted to change it. It allows for the extra 5mm from the printing.</a:t>
-            </a:r>
+              <a:t>The Solution </a:t>
+            </a:r>
+          </a:p>
+          <a:p>
+            <a:endParaRPr lang="en-US" sz="1800" dirty="0">
+              <a:latin typeface="Bodoni MT" charset="0"/>
+              <a:cs typeface="Helvetica Neue" charset="0"/>
+            </a:endParaRPr>
+          </a:p>
+          <a:p>
+            <a:endParaRPr lang="en-US" dirty="0">
+              <a:latin typeface="Helvetica Neue" charset="0"/>
+              <a:cs typeface="Helvetica Neue" charset="0"/>
+            </a:endParaRPr>
           </a:p>
         </p:txBody>
       </p:sp>

</xml_diff>